<commit_message>
Document the real-time online deployment
- README: live demo link, browser vs local webcam modes, deployment
  section (CPU-only torch, packages.txt, optional TURN secrets), online results
- PROJECT_CONTEXT and outputs/README updated with online test results
- New screenshot of the deployed app in browser webcam (real-time) mode
- Report and presentation updated: WebRTC mode, deployment, online tests

Co-Authored-By: Claude Opus 5.5 <noreply@anthropic.com>
</commit_message>
<xml_diff>
--- a/presentation/project_presentation.pptx
+++ b/presentation/project_presentation.pptx
@@ -603,7 +603,7 @@
           <a:p>
             <a:r>
               <a:rPr lang="en-US" dirty="0"/>
-              <a:t>The screenshot is from our live test: the person is detected with 0.88 confidence at 23.4 FPS. The code is split into three files: app.py for the UI and loop, detector.py for YOLO, and utils.py for drawing, FPS and counting.</a:t>
+              <a:t>The screenshot is from our live test with the local OpenCV webcam mode: the person is detected with 0.88 confidence at 23.4 FPS. The code is split into three files: app.py for the UI and the webcam modes, detector.py for YOLO, and utils.py for drawing, FPS and counting. The app is also deployed online. There the browser streams the webcam to the app with WebRTC.</a:t>
             </a:r>
             <a:endParaRPr lang="en-US" dirty="0"/>
           </a:p>
@@ -691,7 +691,7 @@
           <a:p>
             <a:r>
               <a:rPr lang="en-US" dirty="0"/>
-              <a:t>These are real measurements from our laptop. The app ran at 22 to 24 FPS, the model needs about 31 ms per frame, and the person in front of the camera was detected with 0.77 to 0.94 confidence. The images show the effect of the threshold: lower values show more, but weaker, detections.</a:t>
+              <a:t>These are real measurements. On our laptop the app ran at 22 to 24 FPS, the model needs about 31 ms per frame, and the person in front of the camera was detected with 0.77 to 0.94 confidence. The online version on Streamlit Community Cloud mostly showed 15 to 24 FPS with a 30 fps test video from Chrome's fake camera. The images show the effect of the threshold: lower values show more, but weaker, detections.</a:t>
             </a:r>
             <a:endParaRPr lang="en-US" dirty="0"/>
           </a:p>
@@ -2853,7 +2853,7 @@
                 <a:ea typeface="Calibri" pitchFamily="34" charset="-122"/>
                 <a:cs typeface="Calibri" pitchFamily="34" charset="-120"/>
               </a:rPr>
-              <a:t>Streamlit page, controls, webcam loop</a:t>
+              <a:t>Streamlit page, controls, webcam modes</a:t>
             </a:r>
             <a:endParaRPr lang="en-US" sz="1500" dirty="0"/>
           </a:p>
@@ -3048,7 +3048,7 @@
                 <a:ea typeface="Calibri" pitchFamily="34" charset="-122"/>
                 <a:cs typeface="Calibri" pitchFamily="34" charset="-120"/>
               </a:rPr>
-              <a:t>About 310 lines of Python in total</a:t>
+              <a:t>About 390 lines of Python in total</a:t>
             </a:r>
             <a:endParaRPr lang="en-US" sz="1500" dirty="0"/>
           </a:p>
@@ -3063,7 +3063,7 @@
         <p:spPr>
           <a:xfrm>
             <a:off x="8001000" y="4983480"/>
-            <a:ext cx="3642055" cy="731520"/>
+            <a:ext cx="3824935" cy="731520"/>
           </a:xfrm>
           <a:prstGeom prst="rect">
             <a:avLst/>
@@ -3079,15 +3079,39 @@
               <a:buNone/>
             </a:pPr>
             <a:r>
-              <a:rPr lang="en-US" sz="1500" dirty="0">
-                <a:solidFill>
-                  <a:srgbClr val="5B6675"/>
+              <a:rPr lang="en-US" sz="1500" b="1" dirty="0">
+                <a:solidFill>
+                  <a:srgbClr val="1F2933"/>
                 </a:solidFill>
                 <a:latin typeface="Calibri" pitchFamily="34" charset="0"/>
                 <a:ea typeface="Calibri" pitchFamily="34" charset="-122"/>
                 <a:cs typeface="Calibri" pitchFamily="34" charset="-120"/>
               </a:rPr>
-              <a:t>Controls: input source, confidence slider, camera index, start/stop toggle</a:t>
+              <a:t>Live online (browser webcam, WebRTC):</a:t>
+            </a:r>
+            <a:endParaRPr lang="en-US" sz="1500" dirty="0"/>
+          </a:p>
+          <a:p>
+            <a:pPr indent="0" marL="0">
+              <a:buNone/>
+            </a:pPr>
+            <a:r>
+              <a:rPr lang="en-US" sz="1300" u="sng" dirty="0">
+                <a:solidFill>
+                  <a:srgbClr val="15803D"/>
+                </a:solidFill>
+                <a:latin typeface="Calibri" pitchFamily="34" charset="0"/>
+                <a:ea typeface="Calibri" pitchFamily="34" charset="-122"/>
+                <a:cs typeface="Calibri" pitchFamily="34" charset="-120"/>
+                <a:hlinkClick r:id="rId2" invalidUrl="" action="" tgtFrame="" tooltip="" history="1" highlightClick="0" endSnd="0">
+                  <a:extLst>
+                    <a:ext uri="{A12FA001-AC4F-418D-AE19-62706E023703}">
+                      <ahyp:hlinkClr xmlns:ahyp="http://schemas.microsoft.com/office/drawing/2018/hyperlinkcolor" val="tx"/>
+                    </a:ext>
+                  </a:extLst>
+                </a:hlinkClick>
+              </a:rPr>
+              <a:t>realtime-object-detection-yolo.streamlit.app</a:t>
             </a:r>
             <a:endParaRPr lang="en-US" sz="1500" dirty="0"/>
           </a:p>
@@ -3222,7 +3246,7 @@
                 <a:ea typeface="Arial" pitchFamily="34" charset="-122"/>
                 <a:cs typeface="Arial" pitchFamily="34" charset="-120"/>
               </a:rPr>
-              <a:t>Results (measured on our laptop)</a:t>
+              <a:t>Results (real measurements)</a:t>
             </a:r>
             <a:endParaRPr lang="en-US" sz="3400" dirty="0"/>
           </a:p>
@@ -3237,7 +3261,7 @@
         <p:spPr>
           <a:xfrm>
             <a:off x="548640" y="1783080"/>
-            <a:ext cx="3520440" cy="868680"/>
+            <a:ext cx="2606040" cy="868680"/>
           </a:xfrm>
           <a:prstGeom prst="rect">
             <a:avLst/>
@@ -3253,7 +3277,7 @@
               <a:buNone/>
             </a:pPr>
             <a:r>
-              <a:rPr lang="en-US" sz="4800" b="1" dirty="0">
+              <a:rPr lang="en-US" sz="4000" b="1" dirty="0">
                 <a:solidFill>
                   <a:srgbClr val="15803D"/>
                 </a:solidFill>
@@ -3263,7 +3287,7 @@
               </a:rPr>
               <a:t>22–24</a:t>
             </a:r>
-            <a:endParaRPr lang="en-US" sz="4800" dirty="0"/>
+            <a:endParaRPr lang="en-US" sz="4000" dirty="0"/>
           </a:p>
         </p:txBody>
       </p:sp>
@@ -3276,7 +3300,7 @@
         <p:spPr>
           <a:xfrm>
             <a:off x="548640" y="2651760"/>
-            <a:ext cx="3520440" cy="365760"/>
+            <a:ext cx="2606040" cy="365760"/>
           </a:xfrm>
           <a:prstGeom prst="rect">
             <a:avLst/>
@@ -3292,7 +3316,7 @@
               <a:buNone/>
             </a:pPr>
             <a:r>
-              <a:rPr lang="en-US" sz="1700" b="1" dirty="0">
+              <a:rPr lang="en-US" sz="1600" b="1" dirty="0">
                 <a:solidFill>
                   <a:srgbClr val="1F2933"/>
                 </a:solidFill>
@@ -3300,9 +3324,9 @@
                 <a:ea typeface="Calibri" pitchFamily="34" charset="-122"/>
                 <a:cs typeface="Calibri" pitchFamily="34" charset="-120"/>
               </a:rPr>
-              <a:t>FPS in the live app</a:t>
-            </a:r>
-            <a:endParaRPr lang="en-US" sz="1700" dirty="0"/>
+              <a:t>FPS on our laptop</a:t>
+            </a:r>
+            <a:endParaRPr lang="en-US" sz="1600" dirty="0"/>
           </a:p>
         </p:txBody>
       </p:sp>
@@ -3315,7 +3339,7 @@
         <p:spPr>
           <a:xfrm>
             <a:off x="548640" y="2999232"/>
-            <a:ext cx="3520440" cy="320040"/>
+            <a:ext cx="2606040" cy="320040"/>
           </a:xfrm>
           <a:prstGeom prst="rect">
             <a:avLst/>
@@ -3331,7 +3355,7 @@
               <a:buNone/>
             </a:pPr>
             <a:r>
-              <a:rPr lang="en-US" sz="1400" dirty="0">
+              <a:rPr lang="en-US" sz="1300" dirty="0">
                 <a:solidFill>
                   <a:srgbClr val="5B6675"/>
                 </a:solidFill>
@@ -3341,7 +3365,7 @@
               </a:rPr>
               <a:t>one browser tab, CPU only</a:t>
             </a:r>
-            <a:endParaRPr lang="en-US" sz="1400" dirty="0"/>
+            <a:endParaRPr lang="en-US" sz="1300" dirty="0"/>
           </a:p>
         </p:txBody>
       </p:sp>
@@ -3353,8 +3377,8 @@
         </p:nvSpPr>
         <p:spPr>
           <a:xfrm>
-            <a:off x="4343400" y="1783080"/>
-            <a:ext cx="3520440" cy="868680"/>
+            <a:off x="3337560" y="1783080"/>
+            <a:ext cx="2606040" cy="868680"/>
           </a:xfrm>
           <a:prstGeom prst="rect">
             <a:avLst/>
@@ -3370,7 +3394,7 @@
               <a:buNone/>
             </a:pPr>
             <a:r>
-              <a:rPr lang="en-US" sz="4800" b="1" dirty="0">
+              <a:rPr lang="en-US" sz="4000" b="1" dirty="0">
                 <a:solidFill>
                   <a:srgbClr val="15803D"/>
                 </a:solidFill>
@@ -3380,7 +3404,7 @@
               </a:rPr>
               <a:t>31 ms</a:t>
             </a:r>
-            <a:endParaRPr lang="en-US" sz="4800" dirty="0"/>
+            <a:endParaRPr lang="en-US" sz="4000" dirty="0"/>
           </a:p>
         </p:txBody>
       </p:sp>
@@ -3392,8 +3416,8 @@
         </p:nvSpPr>
         <p:spPr>
           <a:xfrm>
-            <a:off x="4343400" y="2651760"/>
-            <a:ext cx="3520440" cy="365760"/>
+            <a:off x="3337560" y="2651760"/>
+            <a:ext cx="2606040" cy="365760"/>
           </a:xfrm>
           <a:prstGeom prst="rect">
             <a:avLst/>
@@ -3409,7 +3433,7 @@
               <a:buNone/>
             </a:pPr>
             <a:r>
-              <a:rPr lang="en-US" sz="1700" b="1" dirty="0">
+              <a:rPr lang="en-US" sz="1600" b="1" dirty="0">
                 <a:solidFill>
                   <a:srgbClr val="1F2933"/>
                 </a:solidFill>
@@ -3419,7 +3443,7 @@
               </a:rPr>
               <a:t>YOLO11n per frame</a:t>
             </a:r>
-            <a:endParaRPr lang="en-US" sz="1700" dirty="0"/>
+            <a:endParaRPr lang="en-US" sz="1600" dirty="0"/>
           </a:p>
         </p:txBody>
       </p:sp>
@@ -3431,8 +3455,8 @@
         </p:nvSpPr>
         <p:spPr>
           <a:xfrm>
-            <a:off x="4343400" y="2999232"/>
-            <a:ext cx="3520440" cy="320040"/>
+            <a:off x="3337560" y="2999232"/>
+            <a:ext cx="2606040" cy="320040"/>
           </a:xfrm>
           <a:prstGeom prst="rect">
             <a:avLst/>
@@ -3448,7 +3472,7 @@
               <a:buNone/>
             </a:pPr>
             <a:r>
-              <a:rPr lang="en-US" sz="1400" dirty="0">
+              <a:rPr lang="en-US" sz="1300" dirty="0">
                 <a:solidFill>
                   <a:srgbClr val="5B6675"/>
                 </a:solidFill>
@@ -3458,7 +3482,7 @@
               </a:rPr>
               <a:t>640x480, mean of 50 runs</a:t>
             </a:r>
-            <a:endParaRPr lang="en-US" sz="1400" dirty="0"/>
+            <a:endParaRPr lang="en-US" sz="1300" dirty="0"/>
           </a:p>
         </p:txBody>
       </p:sp>
@@ -3470,8 +3494,8 @@
         </p:nvSpPr>
         <p:spPr>
           <a:xfrm>
-            <a:off x="8138160" y="1783080"/>
-            <a:ext cx="3520440" cy="868680"/>
+            <a:off x="6126480" y="1783080"/>
+            <a:ext cx="2606040" cy="868680"/>
           </a:xfrm>
           <a:prstGeom prst="rect">
             <a:avLst/>
@@ -3487,7 +3511,7 @@
               <a:buNone/>
             </a:pPr>
             <a:r>
-              <a:rPr lang="en-US" sz="4800" b="1" dirty="0">
+              <a:rPr lang="en-US" sz="4000" b="1" dirty="0">
                 <a:solidFill>
                   <a:srgbClr val="15803D"/>
                 </a:solidFill>
@@ -3497,7 +3521,7 @@
               </a:rPr>
               <a:t>0.77–0.94</a:t>
             </a:r>
-            <a:endParaRPr lang="en-US" sz="4800" dirty="0"/>
+            <a:endParaRPr lang="en-US" sz="4000" dirty="0"/>
           </a:p>
         </p:txBody>
       </p:sp>
@@ -3509,8 +3533,8 @@
         </p:nvSpPr>
         <p:spPr>
           <a:xfrm>
-            <a:off x="8138160" y="2651760"/>
-            <a:ext cx="3520440" cy="365760"/>
+            <a:off x="6126480" y="2651760"/>
+            <a:ext cx="2606040" cy="365760"/>
           </a:xfrm>
           <a:prstGeom prst="rect">
             <a:avLst/>
@@ -3526,7 +3550,7 @@
               <a:buNone/>
             </a:pPr>
             <a:r>
-              <a:rPr lang="en-US" sz="1700" b="1" dirty="0">
+              <a:rPr lang="en-US" sz="1600" b="1" dirty="0">
                 <a:solidFill>
                   <a:srgbClr val="1F2933"/>
                 </a:solidFill>
@@ -3536,7 +3560,7 @@
               </a:rPr>
               <a:t>person confidence</a:t>
             </a:r>
-            <a:endParaRPr lang="en-US" sz="1700" dirty="0"/>
+            <a:endParaRPr lang="en-US" sz="1600" dirty="0"/>
           </a:p>
         </p:txBody>
       </p:sp>
@@ -3548,8 +3572,8 @@
         </p:nvSpPr>
         <p:spPr>
           <a:xfrm>
-            <a:off x="8138160" y="2999232"/>
-            <a:ext cx="3520440" cy="320040"/>
+            <a:off x="6126480" y="2999232"/>
+            <a:ext cx="2606040" cy="320040"/>
           </a:xfrm>
           <a:prstGeom prst="rect">
             <a:avLst/>
@@ -3565,7 +3589,7 @@
               <a:buNone/>
             </a:pPr>
             <a:r>
-              <a:rPr lang="en-US" sz="1400" dirty="0">
+              <a:rPr lang="en-US" sz="1300" dirty="0">
                 <a:solidFill>
                   <a:srgbClr val="5B6675"/>
                 </a:solidFill>
@@ -3575,13 +3599,130 @@
               </a:rPr>
               <a:t>52 saved live frames</a:t>
             </a:r>
-            <a:endParaRPr lang="en-US" sz="1400" dirty="0"/>
+            <a:endParaRPr lang="en-US" sz="1300" dirty="0"/>
+          </a:p>
+        </p:txBody>
+      </p:sp>
+      <p:sp>
+        <p:nvSpPr>
+          <p:cNvPr id="14" name="Text 12"/>
+          <p:cNvSpPr txBox="1"/>
+          <p:nvPr/>
+        </p:nvSpPr>
+        <p:spPr>
+          <a:xfrm>
+            <a:off x="8915400" y="1783080"/>
+            <a:ext cx="2606040" cy="868680"/>
+          </a:xfrm>
+          <a:prstGeom prst="rect">
+            <a:avLst/>
+          </a:prstGeom>
+          <a:noFill/>
+          <a:ln/>
+        </p:spPr>
+        <p:txBody>
+          <a:bodyPr wrap="square" lIns="0" tIns="0" rIns="0" bIns="0" rtlCol="0" anchor="ctr"/>
+          <a:lstStyle/>
+          <a:p>
+            <a:pPr indent="0" marL="0">
+              <a:buNone/>
+            </a:pPr>
+            <a:r>
+              <a:rPr lang="en-US" sz="4000" b="1" dirty="0">
+                <a:solidFill>
+                  <a:srgbClr val="15803D"/>
+                </a:solidFill>
+                <a:latin typeface="Arial" pitchFamily="34" charset="0"/>
+                <a:ea typeface="Arial" pitchFamily="34" charset="-122"/>
+                <a:cs typeface="Arial" pitchFamily="34" charset="-120"/>
+              </a:rPr>
+              <a:t>15–24</a:t>
+            </a:r>
+            <a:endParaRPr lang="en-US" sz="4000" dirty="0"/>
+          </a:p>
+        </p:txBody>
+      </p:sp>
+      <p:sp>
+        <p:nvSpPr>
+          <p:cNvPr id="15" name="Text 13"/>
+          <p:cNvSpPr txBox="1"/>
+          <p:nvPr/>
+        </p:nvSpPr>
+        <p:spPr>
+          <a:xfrm>
+            <a:off x="8915400" y="2651760"/>
+            <a:ext cx="2606040" cy="365760"/>
+          </a:xfrm>
+          <a:prstGeom prst="rect">
+            <a:avLst/>
+          </a:prstGeom>
+          <a:noFill/>
+          <a:ln/>
+        </p:spPr>
+        <p:txBody>
+          <a:bodyPr wrap="square" lIns="0" tIns="0" rIns="0" bIns="0" rtlCol="0" anchor="ctr"/>
+          <a:lstStyle/>
+          <a:p>
+            <a:pPr indent="0" marL="0">
+              <a:buNone/>
+            </a:pPr>
+            <a:r>
+              <a:rPr lang="en-US" sz="1600" b="1" dirty="0">
+                <a:solidFill>
+                  <a:srgbClr val="1F2933"/>
+                </a:solidFill>
+                <a:latin typeface="Calibri" pitchFamily="34" charset="0"/>
+                <a:ea typeface="Calibri" pitchFamily="34" charset="-122"/>
+                <a:cs typeface="Calibri" pitchFamily="34" charset="-120"/>
+              </a:rPr>
+              <a:t>FPS online (cloud)</a:t>
+            </a:r>
+            <a:endParaRPr lang="en-US" sz="1600" dirty="0"/>
+          </a:p>
+        </p:txBody>
+      </p:sp>
+      <p:sp>
+        <p:nvSpPr>
+          <p:cNvPr id="16" name="Text 14"/>
+          <p:cNvSpPr txBox="1"/>
+          <p:nvPr/>
+        </p:nvSpPr>
+        <p:spPr>
+          <a:xfrm>
+            <a:off x="8915400" y="2999232"/>
+            <a:ext cx="2606040" cy="320040"/>
+          </a:xfrm>
+          <a:prstGeom prst="rect">
+            <a:avLst/>
+          </a:prstGeom>
+          <a:noFill/>
+          <a:ln/>
+        </p:spPr>
+        <p:txBody>
+          <a:bodyPr wrap="square" lIns="0" tIns="0" rIns="0" bIns="0" rtlCol="0" anchor="ctr"/>
+          <a:lstStyle/>
+          <a:p>
+            <a:pPr indent="0" marL="0">
+              <a:buNone/>
+            </a:pPr>
+            <a:r>
+              <a:rPr lang="en-US" sz="1300" dirty="0">
+                <a:solidFill>
+                  <a:srgbClr val="5B6675"/>
+                </a:solidFill>
+                <a:latin typeface="Calibri" pitchFamily="34" charset="0"/>
+                <a:ea typeface="Calibri" pitchFamily="34" charset="-122"/>
+                <a:cs typeface="Calibri" pitchFamily="34" charset="-120"/>
+              </a:rPr>
+              <a:t>30 fps test video, fake camera</a:t>
+            </a:r>
+            <a:endParaRPr lang="en-US" sz="1300" dirty="0"/>
           </a:p>
         </p:txBody>
       </p:sp>
       <p:pic>
         <p:nvPicPr>
-          <p:cNvPr id="14" name="Image 0" descr="/Users/SmitT/Desktop/objectdetectionusingyolo/Real-Time-Object-Detection-YOLO/outputs/sample_results/threshold_comparison_zidane.jpg">    </p:cNvPr>
+          <p:cNvPr id="17" name="Image 0" descr="/Users/SmitT/Desktop/objectdetectionusingyolo/Real-Time-Object-Detection-YOLO/outputs/sample_results/threshold_comparison_zidane.jpg">    </p:cNvPr>
           <p:cNvPicPr>
             <a:picLocks noChangeAspect="1"/>
           </p:cNvPicPr>
@@ -3605,7 +3746,7 @@
       </p:pic>
       <p:sp>
         <p:nvSpPr>
-          <p:cNvPr id="15" name="Text 12"/>
+          <p:cNvPr id="18" name="Text 15"/>
           <p:cNvSpPr txBox="1"/>
           <p:nvPr/>
         </p:nvSpPr>
@@ -3644,7 +3785,7 @@
       </p:sp>
       <p:sp>
         <p:nvSpPr>
-          <p:cNvPr id="16" name="Text 13"/>
+          <p:cNvPr id="19" name="Text 16"/>
           <p:cNvSpPr txBox="1"/>
           <p:nvPr/>
         </p:nvSpPr>
@@ -3844,7 +3985,7 @@
                 <a:gridCol w="4206240"/>
                 <a:gridCol w="1399032"/>
               </a:tblGrid>
-              <a:tr h="393192">
+              <a:tr h="365760">
                 <a:tc>
                   <a:txBody>
                     <a:bodyPr/>
@@ -4118,7 +4259,7 @@
                   </a:tcPr>
                 </a:tc>
               </a:tr>
-              <a:tr h="393192">
+              <a:tr h="365760">
                 <a:tc>
                   <a:txBody>
                     <a:bodyPr/>
@@ -4392,7 +4533,7 @@
                   </a:tcPr>
                 </a:tc>
               </a:tr>
-              <a:tr h="393192">
+              <a:tr h="365760">
                 <a:tc>
                   <a:txBody>
                     <a:bodyPr/>
@@ -4666,7 +4807,7 @@
                   </a:tcPr>
                 </a:tc>
               </a:tr>
-              <a:tr h="393192">
+              <a:tr h="365760">
                 <a:tc>
                   <a:txBody>
                     <a:bodyPr/>
@@ -4940,7 +5081,7 @@
                   </a:tcPr>
                 </a:tc>
               </a:tr>
-              <a:tr h="393192">
+              <a:tr h="365760">
                 <a:tc>
                   <a:txBody>
                     <a:bodyPr/>
@@ -5214,7 +5355,7 @@
                   </a:tcPr>
                 </a:tc>
               </a:tr>
-              <a:tr h="393192">
+              <a:tr h="365760">
                 <a:tc>
                   <a:txBody>
                     <a:bodyPr/>
@@ -5488,7 +5629,7 @@
                   </a:tcPr>
                 </a:tc>
               </a:tr>
-              <a:tr h="393192">
+              <a:tr h="365760">
                 <a:tc>
                   <a:txBody>
                     <a:bodyPr/>
@@ -5762,7 +5903,7 @@
                   </a:tcPr>
                 </a:tc>
               </a:tr>
-              <a:tr h="393192">
+              <a:tr h="365760">
                 <a:tc>
                   <a:txBody>
                     <a:bodyPr/>
@@ -6036,7 +6177,7 @@
                   </a:tcPr>
                 </a:tc>
               </a:tr>
-              <a:tr h="393192">
+              <a:tr h="365760">
                 <a:tc>
                   <a:txBody>
                     <a:bodyPr/>
@@ -6310,7 +6451,7 @@
                   </a:tcPr>
                 </a:tc>
               </a:tr>
-              <a:tr h="393192">
+              <a:tr h="365760">
                 <a:tc>
                   <a:txBody>
                     <a:bodyPr/>
@@ -6584,6 +6725,280 @@
                   </a:tcPr>
                 </a:tc>
               </a:tr>
+              <a:tr h="365760">
+                <a:tc>
+                  <a:txBody>
+                    <a:bodyPr/>
+                    <a:lstStyle/>
+                    <a:p>
+                      <a:pPr indent="0" marL="0">
+                        <a:buNone/>
+                      </a:pPr>
+                      <a:r>
+                        <a:rPr lang="en-US" sz="1400" dirty="0">
+                          <a:solidFill>
+                            <a:srgbClr val="1F2933"/>
+                          </a:solidFill>
+                          <a:latin typeface="Calibri" pitchFamily="34" charset="0"/>
+                          <a:ea typeface="Calibri" pitchFamily="34" charset="-122"/>
+                          <a:cs typeface="Calibri" pitchFamily="34" charset="-120"/>
+                        </a:rPr>
+                        <a:t>Online real-time (cloud)</a:t>
+                      </a:r>
+                      <a:endParaRPr lang="en-US" sz="1400" dirty="0">
+                        <a:latin typeface="Calibri" charset="0"/>
+                        <a:ea typeface="Calibri" charset="0"/>
+                        <a:cs typeface="Calibri" charset="0"/>
+                      </a:endParaRPr>
+                    </a:p>
+                  </a:txBody>
+                  <a:tcPr marL="101600" marR="101600" marT="38100" marB="38100" anchor="ctr">
+                    <a:lnL w="9525" cap="flat" cmpd="sng" algn="ctr">
+                      <a:solidFill>
+                        <a:srgbClr val="D5DCE3"/>
+                      </a:solidFill>
+                      <a:prstDash val="solid"/>
+                      <a:round/>
+                      <a:headEnd type="none" w="med" len="med"/>
+                      <a:tailEnd type="none" w="med" len="med"/>
+                    </a:lnL>
+                    <a:lnR w="9525" cap="flat" cmpd="sng" algn="ctr">
+                      <a:solidFill>
+                        <a:srgbClr val="D5DCE3"/>
+                      </a:solidFill>
+                      <a:prstDash val="solid"/>
+                      <a:round/>
+                      <a:headEnd type="none" w="med" len="med"/>
+                      <a:tailEnd type="none" w="med" len="med"/>
+                    </a:lnR>
+                    <a:lnT w="9525" cap="flat" cmpd="sng" algn="ctr">
+                      <a:solidFill>
+                        <a:srgbClr val="D5DCE3"/>
+                      </a:solidFill>
+                      <a:prstDash val="solid"/>
+                      <a:round/>
+                      <a:headEnd type="none" w="med" len="med"/>
+                      <a:tailEnd type="none" w="med" len="med"/>
+                    </a:lnT>
+                    <a:lnB w="9525" cap="flat" cmpd="sng" algn="ctr">
+                      <a:solidFill>
+                        <a:srgbClr val="D5DCE3"/>
+                      </a:solidFill>
+                      <a:prstDash val="solid"/>
+                      <a:round/>
+                      <a:headEnd type="none" w="med" len="med"/>
+                      <a:tailEnd type="none" w="med" len="med"/>
+                    </a:lnB>
+                    <a:solidFill>
+                      <a:srgbClr val="F4F6F8"/>
+                    </a:solidFill>
+                  </a:tcPr>
+                </a:tc>
+                <a:tc>
+                  <a:txBody>
+                    <a:bodyPr/>
+                    <a:lstStyle/>
+                    <a:p>
+                      <a:pPr indent="0" marL="0">
+                        <a:buNone/>
+                      </a:pPr>
+                      <a:r>
+                        <a:rPr lang="en-US" sz="1400" dirty="0">
+                          <a:solidFill>
+                            <a:srgbClr val="1F2933"/>
+                          </a:solidFill>
+                          <a:latin typeface="Calibri" pitchFamily="34" charset="0"/>
+                          <a:ea typeface="Calibri" pitchFamily="34" charset="-122"/>
+                          <a:cs typeface="Calibri" pitchFamily="34" charset="-120"/>
+                        </a:rPr>
+                        <a:t>fake camera, 30 fps video</a:t>
+                      </a:r>
+                      <a:endParaRPr lang="en-US" sz="1400" dirty="0">
+                        <a:latin typeface="Calibri" charset="0"/>
+                        <a:ea typeface="Calibri" charset="0"/>
+                        <a:cs typeface="Calibri" charset="0"/>
+                      </a:endParaRPr>
+                    </a:p>
+                  </a:txBody>
+                  <a:tcPr marL="101600" marR="101600" marT="38100" marB="38100" anchor="ctr">
+                    <a:lnL w="9525" cap="flat" cmpd="sng" algn="ctr">
+                      <a:solidFill>
+                        <a:srgbClr val="D5DCE3"/>
+                      </a:solidFill>
+                      <a:prstDash val="solid"/>
+                      <a:round/>
+                      <a:headEnd type="none" w="med" len="med"/>
+                      <a:tailEnd type="none" w="med" len="med"/>
+                    </a:lnL>
+                    <a:lnR w="9525" cap="flat" cmpd="sng" algn="ctr">
+                      <a:solidFill>
+                        <a:srgbClr val="D5DCE3"/>
+                      </a:solidFill>
+                      <a:prstDash val="solid"/>
+                      <a:round/>
+                      <a:headEnd type="none" w="med" len="med"/>
+                      <a:tailEnd type="none" w="med" len="med"/>
+                    </a:lnR>
+                    <a:lnT w="9525" cap="flat" cmpd="sng" algn="ctr">
+                      <a:solidFill>
+                        <a:srgbClr val="D5DCE3"/>
+                      </a:solidFill>
+                      <a:prstDash val="solid"/>
+                      <a:round/>
+                      <a:headEnd type="none" w="med" len="med"/>
+                      <a:tailEnd type="none" w="med" len="med"/>
+                    </a:lnT>
+                    <a:lnB w="9525" cap="flat" cmpd="sng" algn="ctr">
+                      <a:solidFill>
+                        <a:srgbClr val="D5DCE3"/>
+                      </a:solidFill>
+                      <a:prstDash val="solid"/>
+                      <a:round/>
+                      <a:headEnd type="none" w="med" len="med"/>
+                      <a:tailEnd type="none" w="med" len="med"/>
+                    </a:lnB>
+                    <a:solidFill>
+                      <a:srgbClr val="F4F6F8"/>
+                    </a:solidFill>
+                  </a:tcPr>
+                </a:tc>
+                <a:tc>
+                  <a:txBody>
+                    <a:bodyPr/>
+                    <a:lstStyle/>
+                    <a:p>
+                      <a:pPr indent="0" marL="0">
+                        <a:buNone/>
+                      </a:pPr>
+                      <a:r>
+                        <a:rPr lang="en-US" sz="1400" dirty="0">
+                          <a:solidFill>
+                            <a:srgbClr val="1F2933"/>
+                          </a:solidFill>
+                          <a:latin typeface="Calibri" pitchFamily="34" charset="0"/>
+                          <a:ea typeface="Calibri" pitchFamily="34" charset="-122"/>
+                          <a:cs typeface="Calibri" pitchFamily="34" charset="-120"/>
+                        </a:rPr>
+                        <a:t>15–24 FPS, detections correct</a:t>
+                      </a:r>
+                      <a:endParaRPr lang="en-US" sz="1400" dirty="0">
+                        <a:latin typeface="Calibri" charset="0"/>
+                        <a:ea typeface="Calibri" charset="0"/>
+                        <a:cs typeface="Calibri" charset="0"/>
+                      </a:endParaRPr>
+                    </a:p>
+                  </a:txBody>
+                  <a:tcPr marL="101600" marR="101600" marT="38100" marB="38100" anchor="ctr">
+                    <a:lnL w="9525" cap="flat" cmpd="sng" algn="ctr">
+                      <a:solidFill>
+                        <a:srgbClr val="D5DCE3"/>
+                      </a:solidFill>
+                      <a:prstDash val="solid"/>
+                      <a:round/>
+                      <a:headEnd type="none" w="med" len="med"/>
+                      <a:tailEnd type="none" w="med" len="med"/>
+                    </a:lnL>
+                    <a:lnR w="9525" cap="flat" cmpd="sng" algn="ctr">
+                      <a:solidFill>
+                        <a:srgbClr val="D5DCE3"/>
+                      </a:solidFill>
+                      <a:prstDash val="solid"/>
+                      <a:round/>
+                      <a:headEnd type="none" w="med" len="med"/>
+                      <a:tailEnd type="none" w="med" len="med"/>
+                    </a:lnR>
+                    <a:lnT w="9525" cap="flat" cmpd="sng" algn="ctr">
+                      <a:solidFill>
+                        <a:srgbClr val="D5DCE3"/>
+                      </a:solidFill>
+                      <a:prstDash val="solid"/>
+                      <a:round/>
+                      <a:headEnd type="none" w="med" len="med"/>
+                      <a:tailEnd type="none" w="med" len="med"/>
+                    </a:lnT>
+                    <a:lnB w="9525" cap="flat" cmpd="sng" algn="ctr">
+                      <a:solidFill>
+                        <a:srgbClr val="D5DCE3"/>
+                      </a:solidFill>
+                      <a:prstDash val="solid"/>
+                      <a:round/>
+                      <a:headEnd type="none" w="med" len="med"/>
+                      <a:tailEnd type="none" w="med" len="med"/>
+                    </a:lnB>
+                    <a:solidFill>
+                      <a:srgbClr val="F4F6F8"/>
+                    </a:solidFill>
+                  </a:tcPr>
+                </a:tc>
+                <a:tc>
+                  <a:txBody>
+                    <a:bodyPr/>
+                    <a:lstStyle/>
+                    <a:p>
+                      <a:pPr indent="0" marL="0">
+                        <a:buNone/>
+                      </a:pPr>
+                      <a:r>
+                        <a:rPr lang="en-US" sz="1400" b="1" dirty="0">
+                          <a:solidFill>
+                            <a:srgbClr val="15803D"/>
+                          </a:solidFill>
+                          <a:latin typeface="Calibri" pitchFamily="34" charset="0"/>
+                          <a:ea typeface="Calibri" pitchFamily="34" charset="-122"/>
+                          <a:cs typeface="Calibri" pitchFamily="34" charset="-120"/>
+                        </a:rPr>
+                        <a:t>Pass</a:t>
+                      </a:r>
+                      <a:endParaRPr lang="en-US" sz="1400" dirty="0">
+                        <a:latin typeface="Calibri" charset="0"/>
+                        <a:ea typeface="Calibri" charset="0"/>
+                        <a:cs typeface="Calibri" charset="0"/>
+                      </a:endParaRPr>
+                    </a:p>
+                  </a:txBody>
+                  <a:tcPr marL="101600" marR="101600" marT="38100" marB="38100" anchor="ctr">
+                    <a:lnL w="9525" cap="flat" cmpd="sng" algn="ctr">
+                      <a:solidFill>
+                        <a:srgbClr val="D5DCE3"/>
+                      </a:solidFill>
+                      <a:prstDash val="solid"/>
+                      <a:round/>
+                      <a:headEnd type="none" w="med" len="med"/>
+                      <a:tailEnd type="none" w="med" len="med"/>
+                    </a:lnL>
+                    <a:lnR w="9525" cap="flat" cmpd="sng" algn="ctr">
+                      <a:solidFill>
+                        <a:srgbClr val="D5DCE3"/>
+                      </a:solidFill>
+                      <a:prstDash val="solid"/>
+                      <a:round/>
+                      <a:headEnd type="none" w="med" len="med"/>
+                      <a:tailEnd type="none" w="med" len="med"/>
+                    </a:lnR>
+                    <a:lnT w="9525" cap="flat" cmpd="sng" algn="ctr">
+                      <a:solidFill>
+                        <a:srgbClr val="D5DCE3"/>
+                      </a:solidFill>
+                      <a:prstDash val="solid"/>
+                      <a:round/>
+                      <a:headEnd type="none" w="med" len="med"/>
+                      <a:tailEnd type="none" w="med" len="med"/>
+                    </a:lnT>
+                    <a:lnB w="9525" cap="flat" cmpd="sng" algn="ctr">
+                      <a:solidFill>
+                        <a:srgbClr val="D5DCE3"/>
+                      </a:solidFill>
+                      <a:prstDash val="solid"/>
+                      <a:round/>
+                      <a:headEnd type="none" w="med" len="med"/>
+                      <a:tailEnd type="none" w="med" len="med"/>
+                    </a:lnB>
+                    <a:solidFill>
+                      <a:srgbClr val="F4F6F8"/>
+                    </a:solidFill>
+                  </a:tcPr>
+                </a:tc>
+              </a:tr>
             </a:tbl>
           </a:graphicData>
         </a:graphic>
@@ -6621,7 +7036,7 @@
                 <a:ea typeface="Calibri" pitchFamily="34" charset="-122"/>
                 <a:cs typeface="Calibri" pitchFamily="34" charset="-120"/>
               </a:rPr>
-              <a:t>* limit found. Lighting and distance were simulated with OpenCV. Multi-object and multi-person cases used sample images.</a:t>
+              <a:t>* limit found. Lighting and distance were simulated with OpenCV. Multi-object and multi-person cases used sample images. The online test used Chrome's fake camera, not a real one.</a:t>
             </a:r>
             <a:endParaRPr lang="en-US" sz="1100" dirty="0"/>
           </a:p>
@@ -6996,7 +7411,7 @@
                 <a:ea typeface="Calibri" pitchFamily="34" charset="-122"/>
                 <a:cs typeface="Calibri" pitchFamily="34" charset="-120"/>
               </a:rPr>
-              <a:t>Webcam must be on the computer running the app</a:t>
+              <a:t>Online: shared cloud CPU; some networks need a TURN server</a:t>
             </a:r>
             <a:endParaRPr lang="en-US" sz="1700" dirty="0"/>
           </a:p>
@@ -7385,7 +7800,7 @@
         </p:nvSpPr>
         <p:spPr>
           <a:xfrm>
-            <a:off x="640080" y="2377440"/>
+            <a:off x="640080" y="2194560"/>
             <a:ext cx="201168" cy="201168"/>
           </a:xfrm>
           <a:prstGeom prst="rect">
@@ -7410,8 +7825,8 @@
         </p:nvSpPr>
         <p:spPr>
           <a:xfrm>
-            <a:off x="1051560" y="2286000"/>
-            <a:ext cx="10424160" cy="731520"/>
+            <a:off x="1051560" y="2103120"/>
+            <a:ext cx="10424160" cy="685800"/>
           </a:xfrm>
           <a:prstGeom prst="rect">
             <a:avLst/>
@@ -7427,7 +7842,7 @@
               <a:buNone/>
             </a:pPr>
             <a:r>
-              <a:rPr lang="en-US" sz="1900" b="1" dirty="0">
+              <a:rPr lang="en-US" sz="1800" b="1" dirty="0">
                 <a:solidFill>
                   <a:srgbClr val="FFFFFF"/>
                 </a:solidFill>
@@ -7441,7 +7856,7 @@
               <a:buNone/>
             </a:pPr>
             <a:r>
-              <a:rPr lang="en-US" sz="1900" dirty="0">
+              <a:rPr lang="en-US" sz="1800" dirty="0">
                 <a:solidFill>
                   <a:srgbClr val="C9D3DC"/>
                 </a:solidFill>
@@ -7451,7 +7866,7 @@
               </a:rPr>
               <a:t>webcam → OpenCV → YOLO11n → Streamlit at about 22–24 FPS on a laptop CPU.</a:t>
             </a:r>
-            <a:endParaRPr lang="en-US" sz="1900" dirty="0"/>
+            <a:endParaRPr lang="en-US" sz="1800" dirty="0"/>
           </a:p>
         </p:txBody>
       </p:sp>
@@ -7463,7 +7878,7 @@
         </p:nvSpPr>
         <p:spPr>
           <a:xfrm>
-            <a:off x="640080" y="3246120"/>
+            <a:off x="640080" y="2926080"/>
             <a:ext cx="201168" cy="201168"/>
           </a:xfrm>
           <a:prstGeom prst="rect">
@@ -7488,8 +7903,8 @@
         </p:nvSpPr>
         <p:spPr>
           <a:xfrm>
-            <a:off x="1051560" y="3154680"/>
-            <a:ext cx="10424160" cy="731520"/>
+            <a:off x="1051560" y="2834640"/>
+            <a:ext cx="10424160" cy="685800"/>
           </a:xfrm>
           <a:prstGeom prst="rect">
             <a:avLst/>
@@ -7505,7 +7920,7 @@
               <a:buNone/>
             </a:pPr>
             <a:r>
-              <a:rPr lang="en-US" sz="1900" b="1" dirty="0">
+              <a:rPr lang="en-US" sz="1800" b="1" dirty="0">
                 <a:solidFill>
                   <a:srgbClr val="FFFFFF"/>
                 </a:solidFill>
@@ -7519,7 +7934,7 @@
               <a:buNone/>
             </a:pPr>
             <a:r>
-              <a:rPr lang="en-US" sz="1900" dirty="0">
+              <a:rPr lang="en-US" sz="1800" dirty="0">
                 <a:solidFill>
                   <a:srgbClr val="C9D3DC"/>
                 </a:solidFill>
@@ -7529,7 +7944,7 @@
               </a:rPr>
               <a:t>the YOLO model is pretrained by Ultralytics. Our work is the integration, testing and documentation.</a:t>
             </a:r>
-            <a:endParaRPr lang="en-US" sz="1900" dirty="0"/>
+            <a:endParaRPr lang="en-US" sz="1800" dirty="0"/>
           </a:p>
         </p:txBody>
       </p:sp>
@@ -7541,7 +7956,7 @@
         </p:nvSpPr>
         <p:spPr>
           <a:xfrm>
-            <a:off x="640080" y="4114800"/>
+            <a:off x="640080" y="3657600"/>
             <a:ext cx="201168" cy="201168"/>
           </a:xfrm>
           <a:prstGeom prst="rect">
@@ -7566,8 +7981,8 @@
         </p:nvSpPr>
         <p:spPr>
           <a:xfrm>
-            <a:off x="1051560" y="4023360"/>
-            <a:ext cx="10424160" cy="731520"/>
+            <a:off x="1051560" y="3566160"/>
+            <a:ext cx="10424160" cy="685800"/>
           </a:xfrm>
           <a:prstGeom prst="rect">
             <a:avLst/>
@@ -7583,7 +7998,7 @@
               <a:buNone/>
             </a:pPr>
             <a:r>
-              <a:rPr lang="en-US" sz="1900" b="1" dirty="0">
+              <a:rPr lang="en-US" sz="1800" b="1" dirty="0">
                 <a:solidFill>
                   <a:srgbClr val="FFFFFF"/>
                 </a:solidFill>
@@ -7591,13 +8006,13 @@
                 <a:ea typeface="Calibri" pitchFamily="34" charset="-122"/>
                 <a:cs typeface="Calibri" pitchFamily="34" charset="-120"/>
               </a:rPr>
-              <a:t>Easy to explain: </a:t>
+              <a:t>Online too: </a:t>
             </a:r>
             <a:pPr indent="0" marL="0">
               <a:buNone/>
             </a:pPr>
             <a:r>
-              <a:rPr lang="en-US" sz="1900" dirty="0">
+              <a:rPr lang="en-US" sz="1800" dirty="0">
                 <a:solidFill>
                   <a:srgbClr val="C9D3DC"/>
                 </a:solidFill>
@@ -7605,15 +8020,93 @@
                 <a:ea typeface="Calibri" pitchFamily="34" charset="-122"/>
                 <a:cs typeface="Calibri" pitchFamily="34" charset="-120"/>
               </a:rPr>
-              <a:t>3 small Python files, about 310 lines, only 4 packages.</a:t>
-            </a:r>
-            <a:endParaRPr lang="en-US" sz="1900" dirty="0"/>
+              <a:t>realtime-object-detection-yolo.streamlit.app (browser webcam via WebRTC).</a:t>
+            </a:r>
+            <a:endParaRPr lang="en-US" sz="1800" dirty="0"/>
           </a:p>
         </p:txBody>
       </p:sp>
       <p:sp>
         <p:nvSpPr>
           <p:cNvPr id="11" name="Shape 9"/>
+          <p:cNvSpPr/>
+          <p:nvPr/>
+        </p:nvSpPr>
+        <p:spPr>
+          <a:xfrm>
+            <a:off x="640080" y="4389120"/>
+            <a:ext cx="201168" cy="201168"/>
+          </a:xfrm>
+          <a:prstGeom prst="rect">
+            <a:avLst/>
+          </a:prstGeom>
+          <a:solidFill>
+            <a:srgbClr val="16A34A"/>
+          </a:solidFill>
+          <a:ln w="12700">
+            <a:solidFill>
+              <a:srgbClr val="16A34A"/>
+            </a:solidFill>
+            <a:prstDash val="solid"/>
+          </a:ln>
+        </p:spPr>
+      </p:sp>
+      <p:sp>
+        <p:nvSpPr>
+          <p:cNvPr id="12" name="Text 10"/>
+          <p:cNvSpPr txBox="1"/>
+          <p:nvPr/>
+        </p:nvSpPr>
+        <p:spPr>
+          <a:xfrm>
+            <a:off x="1051560" y="4297680"/>
+            <a:ext cx="10424160" cy="685800"/>
+          </a:xfrm>
+          <a:prstGeom prst="rect">
+            <a:avLst/>
+          </a:prstGeom>
+          <a:noFill/>
+          <a:ln/>
+        </p:spPr>
+        <p:txBody>
+          <a:bodyPr wrap="square" lIns="0" tIns="0" rIns="0" bIns="0" rtlCol="0" anchor="t"/>
+          <a:lstStyle/>
+          <a:p>
+            <a:pPr indent="0" marL="0">
+              <a:buNone/>
+            </a:pPr>
+            <a:r>
+              <a:rPr lang="en-US" sz="1800" b="1" dirty="0">
+                <a:solidFill>
+                  <a:srgbClr val="FFFFFF"/>
+                </a:solidFill>
+                <a:latin typeface="Calibri" pitchFamily="34" charset="0"/>
+                <a:ea typeface="Calibri" pitchFamily="34" charset="-122"/>
+                <a:cs typeface="Calibri" pitchFamily="34" charset="-120"/>
+              </a:rPr>
+              <a:t>Easy to explain: </a:t>
+            </a:r>
+            <a:pPr indent="0" marL="0">
+              <a:buNone/>
+            </a:pPr>
+            <a:r>
+              <a:rPr lang="en-US" sz="1800" dirty="0">
+                <a:solidFill>
+                  <a:srgbClr val="C9D3DC"/>
+                </a:solidFill>
+                <a:latin typeface="Calibri" pitchFamily="34" charset="0"/>
+                <a:ea typeface="Calibri" pitchFamily="34" charset="-122"/>
+                <a:cs typeface="Calibri" pitchFamily="34" charset="-120"/>
+              </a:rPr>
+              <a:t>3 small Python files, about 390 lines, 5 packages.</a:t>
+            </a:r>
+            <a:endParaRPr lang="en-US" sz="1800" dirty="0"/>
+          </a:p>
+        </p:txBody>
+      </p:sp>
+      <p:sp>
+        <p:nvSpPr>
+          <p:cNvPr id="13" name="Shape 11"/>
           <p:cNvSpPr/>
           <p:nvPr/>
         </p:nvSpPr>
@@ -7636,7 +8129,7 @@
       </p:sp>
       <p:sp>
         <p:nvSpPr>
-          <p:cNvPr id="12" name="Shape 10"/>
+          <p:cNvPr id="14" name="Shape 12"/>
           <p:cNvSpPr/>
           <p:nvPr/>
         </p:nvSpPr>
@@ -7659,7 +8152,7 @@
       </p:sp>
       <p:sp>
         <p:nvSpPr>
-          <p:cNvPr id="13" name="Shape 11"/>
+          <p:cNvPr id="15" name="Shape 13"/>
           <p:cNvSpPr/>
           <p:nvPr/>
         </p:nvSpPr>
@@ -7682,7 +8175,7 @@
       </p:sp>
       <p:sp>
         <p:nvSpPr>
-          <p:cNvPr id="14" name="Shape 12"/>
+          <p:cNvPr id="16" name="Shape 14"/>
           <p:cNvSpPr/>
           <p:nvPr/>
         </p:nvSpPr>
@@ -7705,7 +8198,7 @@
       </p:sp>
       <p:sp>
         <p:nvSpPr>
-          <p:cNvPr id="15" name="Shape 13"/>
+          <p:cNvPr id="17" name="Shape 15"/>
           <p:cNvSpPr/>
           <p:nvPr/>
         </p:nvSpPr>
@@ -7728,7 +8221,7 @@
       </p:sp>
       <p:sp>
         <p:nvSpPr>
-          <p:cNvPr id="16" name="Shape 14"/>
+          <p:cNvPr id="18" name="Shape 16"/>
           <p:cNvSpPr/>
           <p:nvPr/>
         </p:nvSpPr>
@@ -7751,7 +8244,7 @@
       </p:sp>
       <p:sp>
         <p:nvSpPr>
-          <p:cNvPr id="17" name="Shape 15"/>
+          <p:cNvPr id="19" name="Shape 17"/>
           <p:cNvSpPr/>
           <p:nvPr/>
         </p:nvSpPr>
@@ -7774,7 +8267,7 @@
       </p:sp>
       <p:sp>
         <p:nvSpPr>
-          <p:cNvPr id="18" name="Shape 16"/>
+          <p:cNvPr id="20" name="Shape 18"/>
           <p:cNvSpPr/>
           <p:nvPr/>
         </p:nvSpPr>
@@ -7797,7 +8290,7 @@
       </p:sp>
       <p:sp>
         <p:nvSpPr>
-          <p:cNvPr id="19" name="Text 17"/>
+          <p:cNvPr id="21" name="Text 19"/>
           <p:cNvSpPr txBox="1"/>
           <p:nvPr/>
         </p:nvSpPr>
@@ -12695,7 +13188,7 @@
                 <a:ea typeface="Calibri" pitchFamily="34" charset="-122"/>
                 <a:cs typeface="Calibri" pitchFamily="34" charset="-120"/>
               </a:rPr>
-              <a:t>Everything runs locally on the laptop: no backend server, no database, no cloud. Streamlit is the only UI framework.</a:t>
+              <a:t>Runs on the laptop or online on Streamlit Community Cloud. Online, the browser streams the webcam to the app with WebRTC. No separate backend, no database.</a:t>
             </a:r>
             <a:endParaRPr lang="en-US" sz="1600" dirty="0"/>
           </a:p>
@@ -14762,7 +15255,7 @@
                 <a:ea typeface="Calibri" pitchFamily="34" charset="-122"/>
                 <a:cs typeface="Calibri" pitchFamily="34" charset="-120"/>
               </a:rPr>
-              <a:t>PyTorch 2.14 runs the network (installed with Ultralytics), NumPy decodes uploaded images.</a:t>
+              <a:t>streamlit-webrtc streams the browser webcam (WebRTC) for the online version. PyTorch 2.14 runs the network, NumPy decodes images.</a:t>
             </a:r>
             <a:endParaRPr lang="en-US" sz="1500" dirty="0"/>
           </a:p>
@@ -14815,7 +15308,7 @@
                 <a:ea typeface="Calibri" pitchFamily="34" charset="-122"/>
                 <a:cs typeface="Calibri" pitchFamily="34" charset="-120"/>
               </a:rPr>
-              <a:t>FastAPI/Flask, databases, React, Docker, cloud services, model training.</a:t>
+              <a:t>FastAPI/Flask, databases, React, Docker, model training.</a:t>
             </a:r>
             <a:endParaRPr lang="en-US" sz="1500" dirty="0"/>
           </a:p>

</xml_diff>